<commit_message>
Update presentation with corrections
</commit_message>
<xml_diff>
--- a/IPEDS_Data_Quality_Python_Presentation.pptx
+++ b/IPEDS_Data_Quality_Python_Presentation.pptx
@@ -219,7 +219,7 @@
           <a:p>
             <a:fld id="{7DAFFF0B-F026-4B59-B842-344CC528DAE8}" type="datetimeFigureOut">
               <a:rPr lang="en-US" smtClean="0"/>
-              <a:t>4/30/2026</a:t>
+              <a:t>6/25/2026</a:t>
             </a:fld>
             <a:endParaRPr lang="en-US"/>
           </a:p>
@@ -913,7 +913,7 @@
             <a:fld id="{E9462EF3-3C4F-43EE-ACEE-D4B806740EA3}" type="datetimeFigureOut">
               <a:rPr lang="en-US" smtClean="0"/>
               <a:pPr/>
-              <a:t>4/30/2026</a:t>
+              <a:t>6/25/2026</a:t>
             </a:fld>
             <a:endParaRPr lang="en-US" dirty="0"/>
           </a:p>
@@ -1176,7 +1176,7 @@
           <a:p>
             <a:fld id="{5568300E-C023-45CD-A0BE-EDB7A8C6EA8B}" type="datetimeFigureOut">
               <a:rPr lang="en-US" smtClean="0"/>
-              <a:t>4/30/2026</a:t>
+              <a:t>6/25/2026</a:t>
             </a:fld>
             <a:endParaRPr lang="en-US" dirty="0"/>
           </a:p>
@@ -1412,7 +1412,7 @@
           <a:p>
             <a:fld id="{3B620EAD-E369-4933-8469-ED7764B56A1B}" type="datetimeFigureOut">
               <a:rPr lang="en-US" smtClean="0"/>
-              <a:t>4/30/2026</a:t>
+              <a:t>6/25/2026</a:t>
             </a:fld>
             <a:endParaRPr lang="en-US" dirty="0"/>
           </a:p>
@@ -1978,7 +1978,7 @@
           <a:p>
             <a:fld id="{1ADDA17D-0BEA-4E76-A7FC-F7C188BC48D1}" type="datetimeFigureOut">
               <a:rPr lang="en-US" dirty="0"/>
-              <a:t>4/30/2026</a:t>
+              <a:t>6/25/2026</a:t>
             </a:fld>
             <a:endParaRPr lang="en-US" dirty="0"/>
           </a:p>
@@ -2205,7 +2205,7 @@
           <a:p>
             <a:fld id="{076C0EF2-9919-473B-8215-8616BAF10692}" type="datetimeFigureOut">
               <a:rPr lang="en-US" smtClean="0"/>
-              <a:t>4/30/2026</a:t>
+              <a:t>6/25/2026</a:t>
             </a:fld>
             <a:endParaRPr lang="en-US" dirty="0"/>
           </a:p>
@@ -2513,7 +2513,7 @@
           <a:p>
             <a:fld id="{A09472EB-AC54-4713-BFC2-BEB621108C63}" type="datetimeFigureOut">
               <a:rPr lang="en-US" smtClean="0"/>
-              <a:t>4/30/2026</a:t>
+              <a:t>6/25/2026</a:t>
             </a:fld>
             <a:endParaRPr lang="en-US" dirty="0"/>
           </a:p>
@@ -2823,7 +2823,7 @@
           <a:p>
             <a:fld id="{99455A0C-791E-4545-B787-F98AD45CD761}" type="datetimeFigureOut">
               <a:rPr lang="en-US" smtClean="0"/>
-              <a:t>4/30/2026</a:t>
+              <a:t>6/25/2026</a:t>
             </a:fld>
             <a:endParaRPr lang="en-US" dirty="0"/>
           </a:p>
@@ -3253,7 +3253,7 @@
           <a:p>
             <a:fld id="{42536B77-F4F4-4427-AC4F-9A623798AD82}" type="datetimeFigureOut">
               <a:rPr lang="en-US" smtClean="0"/>
-              <a:t>4/30/2026</a:t>
+              <a:t>6/25/2026</a:t>
             </a:fld>
             <a:endParaRPr lang="en-US" dirty="0"/>
           </a:p>
@@ -3349,7 +3349,7 @@
           <a:p>
             <a:fld id="{D8BE790C-34EB-4565-8437-CACF4CDB7822}" type="datetimeFigureOut">
               <a:rPr lang="en-US" smtClean="0"/>
-              <a:t>4/30/2026</a:t>
+              <a:t>6/25/2026</a:t>
             </a:fld>
             <a:endParaRPr lang="en-US" dirty="0"/>
           </a:p>
@@ -3519,7 +3519,7 @@
           <a:p>
             <a:fld id="{F84A4C11-22B8-4A4E-8126-B3AF6B948A8E}" type="datetimeFigureOut">
               <a:rPr lang="en-US" smtClean="0"/>
-              <a:t>4/30/2026</a:t>
+              <a:t>6/25/2026</a:t>
             </a:fld>
             <a:endParaRPr lang="en-US" dirty="0"/>
           </a:p>
@@ -3898,7 +3898,7 @@
           <a:p>
             <a:fld id="{16ED06B6-C816-4861-964D-15A98395707D}" type="datetimeFigureOut">
               <a:rPr lang="en-US" smtClean="0"/>
-              <a:t>4/30/2026</a:t>
+              <a:t>6/25/2026</a:t>
             </a:fld>
             <a:endParaRPr lang="en-US" dirty="0"/>
           </a:p>
@@ -4188,7 +4188,7 @@
           <a:p>
             <a:fld id="{00B1A8AB-EA7C-4B1B-9D73-E2551851FABE}" type="datetimeFigureOut">
               <a:rPr lang="en-US" smtClean="0"/>
-              <a:t>4/30/2026</a:t>
+              <a:t>6/25/2026</a:t>
             </a:fld>
             <a:endParaRPr lang="en-US" dirty="0"/>
           </a:p>
@@ -4400,7 +4400,7 @@
           <a:p>
             <a:fld id="{90786BE5-D2A3-4BF0-8B30-D7403E61B3DC}" type="datetimeFigureOut">
               <a:rPr lang="en-US" smtClean="0"/>
-              <a:t>4/30/2026</a:t>
+              <a:t>6/25/2026</a:t>
             </a:fld>
             <a:endParaRPr lang="en-US" dirty="0"/>
           </a:p>
@@ -9145,8 +9145,9 @@
           </a:p>
           <a:p>
             <a:pPr lvl="1">
-              <a:buFont typeface="Arial" panose="020B0604020202020204" pitchFamily="34" charset="0"/>
-              <a:buChar char="•"/>
+              <a:buSzPct val="50000"/>
+              <a:buFont typeface="Courier New" panose="02070309020205020404" pitchFamily="49" charset="0"/>
+              <a:buChar char="o"/>
             </a:pPr>
             <a:r>
               <a:rPr lang="en-US" dirty="0"/>
@@ -9155,8 +9156,9 @@
           </a:p>
           <a:p>
             <a:pPr lvl="1">
-              <a:buFont typeface="Arial" panose="020B0604020202020204" pitchFamily="34" charset="0"/>
-              <a:buChar char="•"/>
+              <a:buSzPct val="50000"/>
+              <a:buFont typeface="Courier New" panose="02070309020205020404" pitchFamily="49" charset="0"/>
+              <a:buChar char="o"/>
             </a:pPr>
             <a:r>
               <a:rPr lang="en-US" dirty="0"/>

</xml_diff>